<commit_message>
Clase 5: síntesis como argumento encadenado; supuesto 1 con un ejemplo general (encuesta de hogares) y el efecto de repetir filas; clase 6 solo regresión logística
Co-Authored-By: Claude Fable 5.1 <noreply@anthropic.com>
</commit_message>
<xml_diff>
--- a/presentaciones/clase06_regresion_logistica.pptx
+++ b/presentaciones/clase06_regresion_logistica.pptx
@@ -3224,7 +3224,7 @@
                 </a:solidFill>
                 <a:latin typeface="Fira Sans"/>
               </a:rPr>
-              <a:t>Clase 6 · Regresión y logística</a:t>
+              <a:t>Clase 6 · Regresión logística</a:t>
             </a:r>
           </a:p>
         </p:txBody>
@@ -3863,7 +3863,7 @@
                 </a:solidFill>
                 <a:latin typeface="Fira Sans"/>
               </a:rPr>
-              <a:t>1. Lo que ya sabemos leer del summary (repaso de la clase 5).</a:t>
+              <a:t>1. Una respuesta que es sí o no: Bernoulli y binomial.</a:t>
             </a:r>
           </a:p>
           <a:p>
@@ -3891,7 +3891,7 @@
                 </a:solidFill>
                 <a:latin typeface="Fira Sans"/>
               </a:rPr>
-              <a:t>2. Diagnósticos con los residuos (pendiente).</a:t>
+              <a:t>2. Por qué la recta no sirve para un sí o no.</a:t>
             </a:r>
           </a:p>
           <a:p>
@@ -3919,7 +3919,7 @@
                 </a:solidFill>
                 <a:latin typeface="Fira Sans"/>
               </a:rPr>
-              <a:t>3. Evaluar un modelo fuera de la muestra (pendiente).</a:t>
+              <a:t>3. La regresión logística: la recta dentro de una sigmoide, y cómo se lee.</a:t>
             </a:r>
           </a:p>
           <a:p>
@@ -3947,7 +3947,35 @@
                 </a:solidFill>
                 <a:latin typeface="Fira Sans"/>
               </a:rPr>
-              <a:t>4. Otro modelo, el mismo lector: regresión logística para un sí o no.</a:t>
+              <a:t>4. El mismo summary: coeficientes, error estándar, z y valor p.</a:t>
+            </a:r>
+          </a:p>
+          <a:p>
+            <a:pPr>
+              <a:lnSpc>
+                <a:spcPct val="112000"/>
+              </a:lnSpc>
+              <a:spcAft>
+                <a:spcPts val="900"/>
+              </a:spcAft>
+            </a:pPr>
+            <a:r>
+              <a:rPr sz="1800" b="1">
+                <a:solidFill>
+                  <a:srgbClr val="E0A437"/>
+                </a:solidFill>
+                <a:latin typeface="Fira Sans"/>
+              </a:rPr>
+              <a:t>▸ </a:t>
+            </a:r>
+            <a:r>
+              <a:rPr sz="1800" b="0">
+                <a:solidFill>
+                  <a:srgbClr val="000000"/>
+                </a:solidFill>
+                <a:latin typeface="Fira Sans"/>
+              </a:rPr>
+              <a:t>5. Clasificar: de la probabilidad a la decisión.</a:t>
             </a:r>
           </a:p>
         </p:txBody>

</xml_diff>

<commit_message>
Clase 6, slide 8: el cálculo de p a la vista (333 / 10.000 = 0,033) en vez de la binomial
Co-Authored-By: Claude Fable 5.1 <noreply@anthropic.com>
</commit_message>
<xml_diff>
--- a/presentaciones/clase06_regresion_logistica.pptx
+++ b/presentaciones/clase06_regresion_logistica.pptx
@@ -8890,8 +8890,8 @@
         </p:blipFill>
         <p:spPr>
           <a:xfrm>
-            <a:off x="699515" y="1297650"/>
-            <a:ext cx="7744968" cy="2534483"/>
+            <a:off x="699515" y="1216993"/>
+            <a:ext cx="7744968" cy="2695797"/>
           </a:xfrm>
           <a:prstGeom prst="rect">
             <a:avLst/>
@@ -8906,7 +8906,7 @@
         </p:nvSpPr>
         <p:spPr>
           <a:xfrm>
-            <a:off x="704088" y="3969293"/>
+            <a:off x="704088" y="4049950"/>
             <a:ext cx="7744968" cy="768096"/>
           </a:xfrm>
           <a:prstGeom prst="rect">
@@ -8927,7 +8927,7 @@
                 </a:solidFill>
                 <a:latin typeface="Fira Sans"/>
               </a:rPr>
-              <a:t>Un cliente es una Bernoulli con probabilidad p de no pagar; la media de la columna de 0 y 1 es la proporción, p = 0,033. Contar los síes entre n clientes da la binomial de la clase 5. La logística modela esa p según x.</a:t>
+              <a:t>p es la proporción de unos en la columna: 333 de 10.000, 0,033. Un cliente al azar es una Bernoulli con esa p; contar los síes entre n clientes sería la binomial de la clase 5. La logística modela esa p según la deuda.</a:t>
             </a:r>
           </a:p>
         </p:txBody>

</xml_diff>

<commit_message>
Clase 6: la recta antes que las fracciones por tramo; slide renombrada 'La probabilidad de no pagar, por tramo de deuda'; notebook reordenado
Co-Authored-By: Claude Fable 5.1 <noreply@anthropic.com>
</commit_message>
<xml_diff>
--- a/presentaciones/clase06_regresion_logistica.pptx
+++ b/presentaciones/clase06_regresion_logistica.pptx
@@ -3458,14 +3458,14 @@
                 </a:solidFill>
                 <a:latin typeface="Fira Sans"/>
               </a:rPr>
-              <a:t>De dónde salen las probabilidades</a:t>
+              <a:t>Por qué la recta no sirve</a:t>
             </a:r>
           </a:p>
         </p:txBody>
       </p:sp>
       <p:pic>
         <p:nvPicPr>
-          <p:cNvPr id="4" name="Picture 3" descr="c6_25_fracciones.png"/>
+          <p:cNvPr id="4" name="Picture 3" descr="c6_04_recta_vs_curva.png"/>
           <p:cNvPicPr>
             <a:picLocks noChangeAspect="1"/>
           </p:cNvPicPr>
@@ -3479,8 +3479,8 @@
         </p:blipFill>
         <p:spPr>
           <a:xfrm>
-            <a:off x="699515" y="1182080"/>
-            <a:ext cx="7744968" cy="2765624"/>
+            <a:off x="1020704" y="1143000"/>
+            <a:ext cx="7102590" cy="2843784"/>
           </a:xfrm>
           <a:prstGeom prst="rect">
             <a:avLst/>
@@ -3495,7 +3495,7 @@
         </p:nvSpPr>
         <p:spPr>
           <a:xfrm>
-            <a:off x="704088" y="4084863"/>
+            <a:off x="704088" y="4123944"/>
             <a:ext cx="7744968" cy="768096"/>
           </a:xfrm>
           <a:prstGeom prst="rect">
@@ -3516,7 +3516,7 @@
                 </a:solidFill>
                 <a:latin typeface="Fira Sans"/>
               </a:rPr>
-              <a:t>Se agrupan los clientes por tramo de deuda y en cada tramo se cuenta cuántos dejaron de pagar. La fracción es la probabilidad de no pagar de ese tramo, estimada con los datos: casi 0 con deudas bajas, 0,50 entre 1.800 y 2.100 dólares, 1 desde los 2.400.</a:t>
+              <a:t>Nada impide ajustar la recta de la clase 4 con el 0/1 como respuesta, pero una probabilidad vive entre 0 y 1: con deuda 0 la recta da −0,08, y con 2.700 dólares llega solo a 0,28 cuando casi todos esos clientes dejaron de pagar. Hace falta ver qué forma tienen los datos.</a:t>
             </a:r>
           </a:p>
         </p:txBody>
@@ -3612,14 +3612,14 @@
                 </a:solidFill>
                 <a:latin typeface="Fira Sans"/>
               </a:rPr>
-              <a:t>Por qué la recta no sirve</a:t>
+              <a:t>La probabilidad de no pagar, por tramo de deuda</a:t>
             </a:r>
           </a:p>
         </p:txBody>
       </p:sp>
       <p:pic>
         <p:nvPicPr>
-          <p:cNvPr id="4" name="Picture 3" descr="c6_04_recta_vs_curva.png"/>
+          <p:cNvPr id="4" name="Picture 3" descr="c6_25_fracciones.png"/>
           <p:cNvPicPr>
             <a:picLocks noChangeAspect="1"/>
           </p:cNvPicPr>
@@ -3633,8 +3633,8 @@
         </p:blipFill>
         <p:spPr>
           <a:xfrm>
-            <a:off x="699515" y="1148401"/>
-            <a:ext cx="7744968" cy="2832981"/>
+            <a:off x="948575" y="1143000"/>
+            <a:ext cx="7246848" cy="2587752"/>
           </a:xfrm>
           <a:prstGeom prst="rect">
             <a:avLst/>
@@ -3649,8 +3649,8 @@
         </p:nvSpPr>
         <p:spPr>
           <a:xfrm>
-            <a:off x="704088" y="4118542"/>
-            <a:ext cx="7744968" cy="768096"/>
+            <a:off x="704088" y="3867912"/>
+            <a:ext cx="7744968" cy="1024128"/>
           </a:xfrm>
           <a:prstGeom prst="rect">
             <a:avLst/>
@@ -3670,7 +3670,7 @@
                 </a:solidFill>
                 <a:latin typeface="Fira Sans"/>
               </a:rPr>
-              <a:t>Una probabilidad vive entre 0 y 1. La recta da valores negativos con deudas bajas y se queda corta arriba, porque las fracciones suben en forma de S: casi nadie deja de pagar hasta los 1.500 dólares, y casi todos desde los 2.400.</a:t>
+              <a:t>Se agrupan los clientes por tramo de deuda y en cada tramo se cuenta cuántos dejaron de pagar. La fracción es la probabilidad de no pagar de ese tramo, estimada con los datos: casi 0 con deudas bajas, 0,50 entre 1.800 y 2.100 dólares, 1 desde los 2.400. Los nueve puntos tienen forma de S: esa es la curva que hace falta.</a:t>
             </a:r>
           </a:p>
         </p:txBody>

</xml_diff>

<commit_message>
Clase 6: fracciones por tramo en la slide 10 y la recta con sus dos gráficos en la 11, eje y actualizado; notebook en el mismo orden
Co-Authored-By: Claude Fable 5.1 <noreply@anthropic.com>
</commit_message>
<xml_diff>
--- a/presentaciones/clase06_regresion_logistica.pptx
+++ b/presentaciones/clase06_regresion_logistica.pptx
@@ -3458,14 +3458,14 @@
                 </a:solidFill>
                 <a:latin typeface="Fira Sans"/>
               </a:rPr>
-              <a:t>Por qué la recta no sirve</a:t>
+              <a:t>La probabilidad de no pagar, por tramo de deuda</a:t>
             </a:r>
           </a:p>
         </p:txBody>
       </p:sp>
       <p:pic>
         <p:nvPicPr>
-          <p:cNvPr id="4" name="Picture 3" descr="c6_04_recta_vs_curva.png"/>
+          <p:cNvPr id="4" name="Picture 3" descr="c6_25_fracciones.png"/>
           <p:cNvPicPr>
             <a:picLocks noChangeAspect="1"/>
           </p:cNvPicPr>
@@ -3479,8 +3479,8 @@
         </p:blipFill>
         <p:spPr>
           <a:xfrm>
-            <a:off x="1020704" y="1143000"/>
-            <a:ext cx="7102590" cy="2843784"/>
+            <a:off x="948575" y="1143000"/>
+            <a:ext cx="7246848" cy="2587752"/>
           </a:xfrm>
           <a:prstGeom prst="rect">
             <a:avLst/>
@@ -3495,8 +3495,8 @@
         </p:nvSpPr>
         <p:spPr>
           <a:xfrm>
-            <a:off x="704088" y="4123944"/>
-            <a:ext cx="7744968" cy="768096"/>
+            <a:off x="704088" y="3867912"/>
+            <a:ext cx="7744968" cy="1024128"/>
           </a:xfrm>
           <a:prstGeom prst="rect">
             <a:avLst/>
@@ -3516,7 +3516,7 @@
                 </a:solidFill>
                 <a:latin typeface="Fira Sans"/>
               </a:rPr>
-              <a:t>Nada impide ajustar la recta de la clase 4 con el 0/1 como respuesta, pero una probabilidad vive entre 0 y 1: con deuda 0 la recta da −0,08, y con 2.700 dólares llega solo a 0,28 cuando casi todos esos clientes dejaron de pagar. Hace falta ver qué forma tienen los datos.</a:t>
+              <a:t>Se agrupan los clientes por tramo de deuda y en cada tramo se cuenta cuántos dejaron de pagar. La fracción es la probabilidad de no pagar de ese tramo, estimada con los datos: casi 0 con deudas bajas, 0,50 entre 1.800 y 2.100 dólares, 1 desde los 2.400. Los nueve puntos tienen forma de S: esa es la curva que hace falta.</a:t>
             </a:r>
           </a:p>
         </p:txBody>
@@ -3612,14 +3612,14 @@
                 </a:solidFill>
                 <a:latin typeface="Fira Sans"/>
               </a:rPr>
-              <a:t>La probabilidad de no pagar, por tramo de deuda</a:t>
+              <a:t>Por qué la recta no sirve</a:t>
             </a:r>
           </a:p>
         </p:txBody>
       </p:sp>
       <p:pic>
         <p:nvPicPr>
-          <p:cNvPr id="4" name="Picture 3" descr="c6_25_fracciones.png"/>
+          <p:cNvPr id="4" name="Picture 3" descr="c6_04_recta_vs_curva.png"/>
           <p:cNvPicPr>
             <a:picLocks noChangeAspect="1"/>
           </p:cNvPicPr>
@@ -3633,8 +3633,8 @@
         </p:blipFill>
         <p:spPr>
           <a:xfrm>
-            <a:off x="948575" y="1143000"/>
-            <a:ext cx="7246848" cy="2587752"/>
+            <a:off x="976654" y="1143000"/>
+            <a:ext cx="7190690" cy="2587752"/>
           </a:xfrm>
           <a:prstGeom prst="rect">
             <a:avLst/>
@@ -3670,7 +3670,7 @@
                 </a:solidFill>
                 <a:latin typeface="Fira Sans"/>
               </a:rPr>
-              <a:t>Se agrupan los clientes por tramo de deuda y en cada tramo se cuenta cuántos dejaron de pagar. La fracción es la probabilidad de no pagar de ese tramo, estimada con los datos: casi 0 con deudas bajas, 0,50 entre 1.800 y 2.100 dólares, 1 desde los 2.400. Los nueve puntos tienen forma de S: esa es la curva que hace falta.</a:t>
+              <a:t>Nada impide ajustar la recta de la clase 4 con el 0/1 como respuesta, pero una probabilidad vive entre 0 y 1: con deuda 0 la recta da −0,08, y a los 2.000 dólares da 0,18 cuando la fracción real es 0,50. Las fracciones suben en forma de S, y la curva de la derecha las sigue: es la regresión logística.</a:t>
             </a:r>
           </a:p>
         </p:txBody>

</xml_diff>